<commit_message>
feat: target repo 신규 커밋 175건 반영 - Merge pull request #6 from Jongwoo0101/feature/frontend-refactor-and-bugfix
refactor: resolve frontend spec issues and fix shared state bug 작성자: 원종우 코드: 223e97a
- fix: recover commute state drift when backend worklog is reset 작성자: dldnwls07 코드: 2771b01
- feat: include participantId in meeting notifications and refactor team store selectors for improved reactivity 작성자: dldnwls07 코드: ffd89bd
- fix: 화상회의 방 재입장 시 호스트/참가자 상태 동기화 및 모달 미표시 버그 수정 작성자: 원종우 코드: 9cc00cd
- fix: SecurityConfig.java @Value 제거
localhost:5173 하드코딩 유지. 대신 새 API 경로들(/api/meetings/**, /api/notifications/**, /api/standup/**) 추가된 것만 반영 작성자: 원종우 코드: 2733dd7
</commit_message>
<xml_diff>
--- a/data/commit_report.pptx
+++ b/data/commit_report.pptx
@@ -3176,7 +3176,7 @@
           <a:lstStyle/>
           <a:p>
             <a:r>
-              <a:t>기능 개발</a:t>
+              <a:t>구조 개선</a:t>
             </a:r>
           </a:p>
         </p:txBody>
@@ -3197,7 +3197,7 @@
           <a:lstStyle/>
           <a:p>
             <a:r>
-              <a:t>2026-05-20</a:t>
+              <a:t>2026-05-22</a:t>
             </a:r>
           </a:p>
           <a:p>
@@ -3207,38 +3207,28 @@
           </a:p>
           <a:p>
             <a:r>
-              <a:t>데일리 스탠드업(목표/결과 작성) 기능 구현 및 실시간 연동</a:t>
+              <a:t>WebSocket 메시지 발신 표준화(WsEnvelope) 및 DTO 최적화</a:t>
             </a:r>
           </a:p>
           <a:p/>
           <a:p>
             <a:r>
-              <a:t>- DailyStandup 엔티티 설계 (member_id + standupDate 유니크 제약 적용)</a:t>
-            </a:r>
-          </a:p>
-          <a:p>
-            <a:r>
-              <a:t>- 하루 시작 시 '오늘의 목표(Goal)' 생성 및 재호출 시 수정 기능 구현</a:t>
-            </a:r>
-          </a:p>
-          <a:p>
-            <a:r>
-              <a:t>- 하루 종료 시 '오늘의 결과(Result)' 작성 기능 구현 및 목표 선작성 유효성 체크 추가</a:t>
-            </a:r>
-          </a:p>
-          <a:p>
-            <a:r>
-              <a:t>- 내 오늘 스탠드업 조회 및 팀 전체 특정 날짜 스탠드업 조회 API 구현</a:t>
-            </a:r>
-          </a:p>
-          <a:p>
-            <a:r>
-              <a:t>- TransactionSynchronization을 활용한 목표/결과 업데이트 시 팀별 웹소켓 실시간 브로드캐스트 적용</a:t>
-            </a:r>
-          </a:p>
-          <a:p>
-            <a:r>
-              <a:t>- 기능 검증용 HTTP API 테스트 스크립트(.http) 작성</a:t>
+              <a:t>- 프론트엔드 통신 표준화를 위한 공통 이벤트 래퍼 `WsEnvelope` 도입 (event, data, occurredAt, version)</a:t>
+            </a:r>
+          </a:p>
+          <a:p>
+            <a:r>
+              <a:t>- `DailyStandupService`, `MeetingRoomService`, `NotificationService`, `StatusService`, `WorkLogService`의 메시지 전송부를 `WsEnvelope` 규격으로 전면 교체 및 이벤트 명 상수화</a:t>
+            </a:r>
+          </a:p>
+          <a:p>
+            <a:r>
+              <a:t>- 브로드캐스트 전용 DTO를 `WsEnvelope.data` 구조에 맞게 경량화 (`TeamStatusBroadcast` -&gt; `TeamStatusPayload`)</a:t>
+            </a:r>
+          </a:p>
+          <a:p>
+            <a:r>
+              <a:t>- 각 도메인 서비스 내 Member 검증 중복 코드를 `getManagedMember` 등 헬퍼 메서드로 추출 및 알림 페이로드(roomPayload 등) 규격화</a:t>
             </a:r>
           </a:p>
         </p:txBody>
@@ -3298,7 +3288,7 @@
           <a:lstStyle/>
           <a:p>
             <a:r>
-              <a:t>2026-05-20</a:t>
+              <a:t>2026-05-22</a:t>
             </a:r>
           </a:p>
           <a:p>
@@ -3308,38 +3298,23 @@
           </a:p>
           <a:p>
             <a:r>
-              <a:t>미팅룸 생성, 초대/참가 요청 및 실시간 이벤트 연동 기능 구현</a:t>
+              <a:t>팀 초대 코드 DB 영속화 적용 및 관리 로직 개선</a:t>
             </a:r>
           </a:p>
           <a:p/>
           <a:p>
             <a:r>
-              <a:t>- MeetingRoom 및 MeetingParticipant 엔티티 설계 (초대 및 참여 요청 일원화 관리)</a:t>
-            </a:r>
-          </a:p>
-          <a:p>
-            <a:r>
-              <a:t>- 미팅룸 생성 및 참여(수락) 시 해당 회원의 상태를 MEETING으로 자동 변경하는 로직 구현</a:t>
-            </a:r>
-          </a:p>
-          <a:p>
-            <a:r>
-              <a:t>- 미팅룸 종료 및 퇴장 시 회원의 상태를 WORKING으로 복귀 처리</a:t>
-            </a:r>
-          </a:p>
-          <a:p>
-            <a:r>
-              <a:t>- 중복 참여 요청 방지 및 주최자 권한 검증 등 도메인 유효성 로직 추가</a:t>
-            </a:r>
-          </a:p>
-          <a:p>
-            <a:r>
-              <a:t>- 팀 전체 브로드캐스트 및 개인별 WebSocket 실시간 알림 기능 적용</a:t>
-            </a:r>
-          </a:p>
-          <a:p>
-            <a:r>
-              <a:t>- 미팅룸 생성/상세조회/참가/초대/종료/퇴장 관련 REST API 구현</a:t>
+              <a:t>- 인메모리(ConcurrentHashMap) 기반 초대 코드 저장을 DB 엔티티(`InviteCode`)로 마이그레이션하여 서버 재시작 시 데이터 유지</a:t>
+            </a:r>
+          </a:p>
+          <a:p>
+            <a:r>
+              <a:t>- 초대 코드 1회성 사용을 위한 `markAsUsed()` 비즈니스 로직 및 검증 추가</a:t>
+            </a:r>
+          </a:p>
+          <a:p>
+            <a:r>
+              <a:t>- 초대 코드 만료 시간(expiration-seconds)을 application.yaml에서 주입받도록 환경변수 처리 개선</a:t>
             </a:r>
           </a:p>
         </p:txBody>
@@ -3378,7 +3353,7 @@
           <a:lstStyle/>
           <a:p>
             <a:r>
-              <a:t>기능 개발</a:t>
+              <a:t>구조 개선</a:t>
             </a:r>
           </a:p>
         </p:txBody>
@@ -3399,43 +3374,17 @@
           <a:lstStyle/>
           <a:p>
             <a:r>
-              <a:t>2026-05-20</a:t>
-            </a:r>
-          </a:p>
-          <a:p>
-            <a:r>
-              <a:t>원종우</a:t>
-            </a:r>
-          </a:p>
-          <a:p>
-            <a:r>
-              <a:t>알림(Notification) 기능 구현 및 실시간 웹소켓 푸시 추가</a:t>
-            </a:r>
-          </a:p>
-          <a:p/>
-          <a:p>
-            <a:r>
-              <a:t>- 일반 알림(GENERAL) 및 중요 알림(IMPORTANT) 도메인 설계</a:t>
-            </a:r>
-          </a:p>
-          <a:p>
-            <a:r>
-              <a:t>- 중요 알림은 수신자가 WORKING/MEETING 상태일 때만 발송 가능하도록 유효성 검증 추가</a:t>
-            </a:r>
-          </a:p>
-          <a:p>
-            <a:r>
-              <a:t>- 트랜잭션 커밋 후 SimpMessagingTemplate을 활용한 WebSocket 실시간 푸시 발송</a:t>
-            </a:r>
-          </a:p>
-          <a:p>
-            <a:r>
-              <a:t>- 알림 전체/단건 조회, 읽지 않은 알림 수(Badge용) 및 읽음 처리 API 구현</a:t>
-            </a:r>
-          </a:p>
-          <a:p>
-            <a:r>
-              <a:t>- API 검증을 위한 HTTP 테스트 스크립트(.http) 작성</a:t>
+              <a:t>2026-05-21</a:t>
+            </a:r>
+          </a:p>
+          <a:p>
+            <a:r>
+              <a:t>dldnwls07</a:t>
+            </a:r>
+          </a:p>
+          <a:p>
+            <a:r>
+              <a:t>simplify joinRoom signature and optimize media stream management in video calls</a:t>
             </a:r>
           </a:p>
         </p:txBody>
@@ -3495,17 +3444,17 @@
           <a:lstStyle/>
           <a:p>
             <a:r>
-              <a:t>2026-05-20</a:t>
-            </a:r>
-          </a:p>
-          <a:p>
-            <a:r>
-              <a:t>원종우</a:t>
-            </a:r>
-          </a:p>
-          <a:p>
-            <a:r>
-              <a:t>Role.java 경로를 enums 패키지로 이동</a:t>
+              <a:t>2026-05-21</a:t>
+            </a:r>
+          </a:p>
+          <a:p>
+            <a:r>
+              <a:t>dldnwls07</a:t>
+            </a:r>
+          </a:p>
+          <a:p>
+            <a:r>
+              <a:t>centralize status UI settings and update dashboard WebSocket event handling</a:t>
             </a:r>
           </a:p>
         </p:txBody>
@@ -3565,12 +3514,12 @@
           <a:lstStyle/>
           <a:p>
             <a:r>
-              <a:t>dldnwls07: 55 commits</a:t>
-            </a:r>
-          </a:p>
-          <a:p>
-            <a:r>
-              <a:t>원종우: 98 commits</a:t>
+              <a:t>원종우: 101 commits</a:t>
+            </a:r>
+          </a:p>
+          <a:p>
+            <a:r>
+              <a:t>dldnwls07: 58 commits</a:t>
             </a:r>
           </a:p>
           <a:p>
@@ -3636,17 +3585,71 @@
           <a:lstStyle/>
           <a:p>
             <a:r>
+              <a:t>2026-05-24</a:t>
+            </a:r>
+          </a:p>
+          <a:p>
+            <a:r>
+              <a:t>- Merge pull request #6 from Jongwoo0101/feature/frontend-refactor-and-bugfix</a:t>
+            </a:r>
+          </a:p>
+          <a:p/>
+          <a:p>
+            <a:r>
+              <a:t> resolve frontend spec issues and fix shared state bug</a:t>
+            </a:r>
+          </a:p>
+          <a:p/>
+          <a:p>
+            <a:r>
+              <a:t>2026-05-23</a:t>
+            </a:r>
+          </a:p>
+          <a:p>
+            <a:r>
+              <a:t>- recover commute state drift when backend worklog is reset</a:t>
+            </a:r>
+          </a:p>
+          <a:p/>
+          <a:p>
+            <a:r>
               <a:t>2026-05-22</a:t>
             </a:r>
           </a:p>
           <a:p>
             <a:r>
-              <a:t>- add audit specification for hardcoding structure mitigation</a:t>
+              <a:t>- resolve frontend spec issues and fix shared state bug</a:t>
             </a:r>
           </a:p>
           <a:p/>
           <a:p>
             <a:r>
+              <a:t>- Segregated Zustand commute store context per employee (fixed shared session bug)</a:t>
+            </a:r>
+          </a:p>
+          <a:p>
+            <a:r>
+              <a:t>- Standardized WebSocket message handling with WS envelope parser</a:t>
+            </a:r>
+          </a:p>
+          <a:p>
+            <a:r>
+              <a:t>- Unified time data sorting with epoch milliseconds</a:t>
+            </a:r>
+          </a:p>
+          <a:p>
+            <a:r>
+              <a:t>- Removed 'any' types for stronger type safety</a:t>
+            </a:r>
+          </a:p>
+          <a:p>
+            <a:r>
+              <a:t>- Separated router pages and content view files</a:t>
+            </a:r>
+          </a:p>
+          <a:p/>
+          <a:p>
+            <a:r>
               <a:t>2026-05-21</a:t>
             </a:r>
           </a:p>
@@ -3763,85 +3766,6 @@
           <a:p>
             <a:r>
               <a:t>- 백엔드 보안 설정 수정 및 프론트엔드 실시간 DB 연동 고도화</a:t>
-            </a:r>
-          </a:p>
-          <a:p/>
-          <a:p>
-            <a:r>
-              <a:t>2026-05-08</a:t>
-            </a:r>
-          </a:p>
-          <a:p>
-            <a:r>
-              <a:t>- Merge pull request #4 from Jongwoo0101/frontend</a:t>
-            </a:r>
-          </a:p>
-          <a:p/>
-          <a:p>
-            <a:r>
-              <a:t>아래 3개 모두 완료</a:t>
-            </a:r>
-          </a:p>
-          <a:p>
-            <a:r>
-              <a:t>POST /api/teams : 실제 팀(Team) 테이블 Entity 생성</a:t>
-            </a:r>
-          </a:p>
-          <a:p>
-            <a:r>
-              <a:t>GET /api/teams/my-team : 직원이 로그인 시 자신이 소속된 팀 조회</a:t>
-            </a:r>
-          </a:p>
-          <a:p>
-            <a:r>
-              <a:t>GET /api/teams/{id}/members : 관리자가 자신의 팀에 소속된 직원 목록 조회</a:t>
-            </a:r>
-          </a:p>
-          <a:p/>
-          <a:p>
-            <a:r>
-              <a:t>2026-05-07</a:t>
-            </a:r>
-          </a:p>
-          <a:p>
-            <a:r>
-              <a:t>- 팀 기반 관리 시스템 구현 및 사파리 호환성 개선</a:t>
-            </a:r>
-          </a:p>
-          <a:p/>
-          <a:p>
-            <a:r>
-              <a:t>- 관리자가 팀을 생성하고 초대 코드를 발급하는 기능 추가</a:t>
-            </a:r>
-          </a:p>
-          <a:p>
-            <a:r>
-              <a:t>- 직원이 코드를 입력하여 팀에 합류하는 기능 추가</a:t>
-            </a:r>
-          </a:p>
-          <a:p>
-            <a:r>
-              <a:t>- 팀별 모니터링 대시보드 구조 설계 (URL 파라미터 기반)</a:t>
-            </a:r>
-          </a:p>
-          <a:p>
-            <a:r>
-              <a:t>- Safari 브라우저에서 fetch/JSON 패턴 에러 해결</a:t>
-            </a:r>
-          </a:p>
-          <a:p>
-            <a:r>
-              <a:t>- 백엔드 응답 필드명(accessToken, virtualBalance) 동기화</a:t>
-            </a:r>
-          </a:p>
-          <a:p>
-            <a:r>
-              <a:t>- zustand와 localStorage를 이용한 오프라인 폴백 시스템 구축</a:t>
-            </a:r>
-          </a:p>
-          <a:p>
-            <a:r>
-              <a:t>- 미사용 InviteEmployeeModal 삭제</a:t>
             </a:r>
           </a:p>
           <a:p/>
@@ -3882,7 +3806,7 @@
           <a:lstStyle/>
           <a:p>
             <a:r>
-              <a:t>기능 개발</a:t>
+              <a:t>버그 수정</a:t>
             </a:r>
           </a:p>
         </p:txBody>
@@ -3903,43 +3827,17 @@
           <a:lstStyle/>
           <a:p>
             <a:r>
-              <a:t>2026-05-22</a:t>
-            </a:r>
-          </a:p>
-          <a:p>
-            <a:r>
-              <a:t>원종우</a:t>
-            </a:r>
-          </a:p>
-          <a:p>
-            <a:r>
-              <a:t>팀 초대 코드 다회성 사용을 위한 1회성 제한 로직 제거</a:t>
-            </a:r>
-          </a:p>
-          <a:p/>
-          <a:p>
-            <a:r>
-              <a:t>[주요 변경 사항]</a:t>
-            </a:r>
-          </a:p>
-          <a:p>
-            <a:r>
-              <a:t>- 기존 1회성 사용 제한으로 인해 다른 팀원이 동일한 코드로 연이어 참가하지 못하던 문제 해결</a:t>
-            </a:r>
-          </a:p>
-          <a:p>
-            <a:r>
-              <a:t>- `InviteCode` 엔티티에서 불필요해진 `used` 필드 및 `markAsUsed()` 상태 변경 메서드 삭제</a:t>
-            </a:r>
-          </a:p>
-          <a:p>
-            <a:r>
-              <a:t>- `InviteCodeRepository`의 쿼리 메서드를 `findByCodeAndUsedFalse`에서 `findByCode`로 단순화</a:t>
-            </a:r>
-          </a:p>
-          <a:p>
-            <a:r>
-              <a:t>- `MemberService.joinTeam()` 내 1회성 처리 로직을 제거하여, 지정된 만료 시간(기본 5분) 내에는 여러 팀원이 무제한으로 코드를 사용할 수 있도록 비즈니스 로직 개선</a:t>
+              <a:t>2026-05-23</a:t>
+            </a:r>
+          </a:p>
+          <a:p>
+            <a:r>
+              <a:t>dldnwls07</a:t>
+            </a:r>
+          </a:p>
+          <a:p>
+            <a:r>
+              <a:t>recover commute state drift when backend worklog is reset</a:t>
             </a:r>
           </a:p>
         </p:txBody>
@@ -3978,7 +3876,7 @@
           <a:lstStyle/>
           <a:p>
             <a:r>
-              <a:t>구조 개선</a:t>
+              <a:t>기능 개발</a:t>
             </a:r>
           </a:p>
         </p:txBody>
@@ -3999,38 +3897,17 @@
           <a:lstStyle/>
           <a:p>
             <a:r>
-              <a:t>2026-05-22</a:t>
-            </a:r>
-          </a:p>
-          <a:p>
-            <a:r>
-              <a:t>원종우</a:t>
-            </a:r>
-          </a:p>
-          <a:p>
-            <a:r>
-              <a:t>WebSocket 메시지 발신 표준화(WsEnvelope) 및 DTO 최적화</a:t>
-            </a:r>
-          </a:p>
-          <a:p/>
-          <a:p>
-            <a:r>
-              <a:t>- 프론트엔드 통신 표준화를 위한 공통 이벤트 래퍼 `WsEnvelope` 도입 (event, data, occurredAt, version)</a:t>
-            </a:r>
-          </a:p>
-          <a:p>
-            <a:r>
-              <a:t>- `DailyStandupService`, `MeetingRoomService`, `NotificationService`, `StatusService`, `WorkLogService`의 메시지 전송부를 `WsEnvelope` 규격으로 전면 교체 및 이벤트 명 상수화</a:t>
-            </a:r>
-          </a:p>
-          <a:p>
-            <a:r>
-              <a:t>- 브로드캐스트 전용 DTO를 `WsEnvelope.data` 구조에 맞게 경량화 (`TeamStatusBroadcast` -&gt; `TeamStatusPayload`)</a:t>
-            </a:r>
-          </a:p>
-          <a:p>
-            <a:r>
-              <a:t>- 각 도메인 서비스 내 Member 검증 중복 코드를 `getManagedMember` 등 헬퍼 메서드로 추출 및 알림 페이로드(roomPayload 등) 규격화</a:t>
+              <a:t>2026-05-23</a:t>
+            </a:r>
+          </a:p>
+          <a:p>
+            <a:r>
+              <a:t>dldnwls07</a:t>
+            </a:r>
+          </a:p>
+          <a:p>
+            <a:r>
+              <a:t>include participantId in meeting notifications and refactor team store selectors for improved reactivity</a:t>
             </a:r>
           </a:p>
         </p:txBody>
@@ -4069,7 +3946,7 @@
           <a:lstStyle/>
           <a:p>
             <a:r>
-              <a:t>기능 개발</a:t>
+              <a:t>버그 수정</a:t>
             </a:r>
           </a:p>
         </p:txBody>
@@ -4090,7 +3967,7 @@
           <a:lstStyle/>
           <a:p>
             <a:r>
-              <a:t>2026-05-22</a:t>
+              <a:t>2026-05-23</a:t>
             </a:r>
           </a:p>
           <a:p>
@@ -4100,23 +3977,7 @@
           </a:p>
           <a:p>
             <a:r>
-              <a:t>팀 초대 코드 DB 영속화 적용 및 관리 로직 개선</a:t>
-            </a:r>
-          </a:p>
-          <a:p/>
-          <a:p>
-            <a:r>
-              <a:t>- 인메모리(ConcurrentHashMap) 기반 초대 코드 저장을 DB 엔티티(`InviteCode`)로 마이그레이션하여 서버 재시작 시 데이터 유지</a:t>
-            </a:r>
-          </a:p>
-          <a:p>
-            <a:r>
-              <a:t>- 초대 코드 1회성 사용을 위한 `markAsUsed()` 비즈니스 로직 및 검증 추가</a:t>
-            </a:r>
-          </a:p>
-          <a:p>
-            <a:r>
-              <a:t>- 초대 코드 만료 시간(expiration-seconds)을 application.yaml에서 주입받도록 환경변수 처리 개선</a:t>
+              <a:t>화상회의 방 재입장 시 호스트/참가자 상태 동기화 및 모달 미표시 버그 수정</a:t>
             </a:r>
           </a:p>
         </p:txBody>
@@ -4155,7 +4016,7 @@
           <a:lstStyle/>
           <a:p>
             <a:r>
-              <a:t>구조 개선</a:t>
+              <a:t>버그 수정</a:t>
             </a:r>
           </a:p>
         </p:txBody>
@@ -4176,17 +4037,22 @@
           <a:lstStyle/>
           <a:p>
             <a:r>
-              <a:t>2026-05-21</a:t>
-            </a:r>
-          </a:p>
-          <a:p>
-            <a:r>
-              <a:t>dldnwls07</a:t>
-            </a:r>
-          </a:p>
-          <a:p>
-            <a:r>
-              <a:t>simplify joinRoom signature and optimize media stream management in video calls</a:t>
+              <a:t>2026-05-23</a:t>
+            </a:r>
+          </a:p>
+          <a:p>
+            <a:r>
+              <a:t>원종우</a:t>
+            </a:r>
+          </a:p>
+          <a:p>
+            <a:r>
+              <a:t>SecurityConfig.java @Value 제거</a:t>
+            </a:r>
+          </a:p>
+          <a:p>
+            <a:r>
+              <a:t>localhost:5173 하드코딩 유지. 대신 새 API 경로들(/api/meetings/**, /api/notifications/**, /api/standup/**) 추가된 것만 반영</a:t>
             </a:r>
           </a:p>
         </p:txBody>
@@ -4246,7 +4112,7 @@
           <a:lstStyle/>
           <a:p>
             <a:r>
-              <a:t>2026-05-21</a:t>
+              <a:t>2026-05-22</a:t>
             </a:r>
           </a:p>
           <a:p>
@@ -4256,7 +4122,33 @@
           </a:p>
           <a:p>
             <a:r>
-              <a:t>centralize status UI settings and update dashboard WebSocket event handling</a:t>
+              <a:t>resolve frontend spec issues and fix shared state bug</a:t>
+            </a:r>
+          </a:p>
+          <a:p/>
+          <a:p>
+            <a:r>
+              <a:t>- Segregated Zustand commute store context per employee (fixed shared session bug)</a:t>
+            </a:r>
+          </a:p>
+          <a:p>
+            <a:r>
+              <a:t>- Standardized WebSocket message handling with WS envelope parser</a:t>
+            </a:r>
+          </a:p>
+          <a:p>
+            <a:r>
+              <a:t>- Unified time data sorting with epoch milliseconds</a:t>
+            </a:r>
+          </a:p>
+          <a:p>
+            <a:r>
+              <a:t>- Removed 'any' types for stronger type safety</a:t>
+            </a:r>
+          </a:p>
+          <a:p>
+            <a:r>
+              <a:t>- Separated router pages and content view files</a:t>
             </a:r>
           </a:p>
         </p:txBody>
@@ -4295,7 +4187,7 @@
           <a:lstStyle/>
           <a:p>
             <a:r>
-              <a:t>구조 개선</a:t>
+              <a:t>기능 개발</a:t>
             </a:r>
           </a:p>
         </p:txBody>
@@ -4316,7 +4208,7 @@
           <a:lstStyle/>
           <a:p>
             <a:r>
-              <a:t>2026-05-20</a:t>
+              <a:t>2026-05-22</a:t>
             </a:r>
           </a:p>
           <a:p>
@@ -4326,7 +4218,33 @@
           </a:p>
           <a:p>
             <a:r>
-              <a:t>status-api-test.http 경로 변경</a:t>
+              <a:t>팀 초대 코드 다회성 사용을 위한 1회성 제한 로직 제거</a:t>
+            </a:r>
+          </a:p>
+          <a:p/>
+          <a:p>
+            <a:r>
+              <a:t>[주요 변경 사항]</a:t>
+            </a:r>
+          </a:p>
+          <a:p>
+            <a:r>
+              <a:t>- 기존 1회성 사용 제한으로 인해 다른 팀원이 동일한 코드로 연이어 참가하지 못하던 문제 해결</a:t>
+            </a:r>
+          </a:p>
+          <a:p>
+            <a:r>
+              <a:t>- `InviteCode` 엔티티에서 불필요해진 `used` 필드 및 `markAsUsed()` 상태 변경 메서드 삭제</a:t>
+            </a:r>
+          </a:p>
+          <a:p>
+            <a:r>
+              <a:t>- `InviteCodeRepository`의 쿼리 메서드를 `findByCodeAndUsedFalse`에서 `findByCode`로 단순화</a:t>
+            </a:r>
+          </a:p>
+          <a:p>
+            <a:r>
+              <a:t>- `MemberService.joinTeam()` 내 1회성 처리 로직을 제거하여, 지정된 만료 시간(기본 5분) 내에는 여러 팀원이 무제한으로 코드를 사용할 수 있도록 비즈니스 로직 개선</a:t>
             </a:r>
           </a:p>
         </p:txBody>

</xml_diff>

<commit_message>
feat: target repo 신규 커밋 1건 반영 - test: just for commit bot test. ignore this commit 작성자: 원종우 코드: 67f2b12
</commit_message>
<xml_diff>
--- a/data/commit_report.pptx
+++ b/data/commit_report.pptx
@@ -9,15 +9,6 @@
     <p:sldId id="257" r:id="rId8"/>
     <p:sldId id="258" r:id="rId9"/>
     <p:sldId id="259" r:id="rId10"/>
-    <p:sldId id="260" r:id="rId11"/>
-    <p:sldId id="261" r:id="rId12"/>
-    <p:sldId id="262" r:id="rId13"/>
-    <p:sldId id="263" r:id="rId14"/>
-    <p:sldId id="264" r:id="rId15"/>
-    <p:sldId id="265" r:id="rId16"/>
-    <p:sldId id="266" r:id="rId17"/>
-    <p:sldId id="267" r:id="rId18"/>
-    <p:sldId id="268" r:id="rId19"/>
   </p:sldIdLst>
   <p:sldSz cx="9144000" cy="6858000" type="screen4x3"/>
   <p:notesSz cx="6858000" cy="9144000"/>
@@ -3150,323 +3141,6 @@
 </p:sld>
 </file>
 
-<file path=ppt/slides/slide10.xml><?xml version="1.0" encoding="utf-8"?>
-<p:sld xmlns:a="http://schemas.openxmlformats.org/drawingml/2006/main" xmlns:p="http://schemas.openxmlformats.org/presentationml/2006/main" xmlns:r="http://schemas.openxmlformats.org/officeDocument/2006/relationships">
-  <p:cSld>
-    <p:spTree>
-      <p:nvGrpSpPr>
-        <p:cNvPr id="1" name=""/>
-        <p:cNvGrpSpPr/>
-        <p:nvPr/>
-      </p:nvGrpSpPr>
-      <p:grpSpPr/>
-      <p:sp>
-        <p:nvSpPr>
-          <p:cNvPr id="2" name="Title 1"/>
-          <p:cNvSpPr>
-            <a:spLocks noGrp="1"/>
-          </p:cNvSpPr>
-          <p:nvPr>
-            <p:ph type="title"/>
-          </p:nvPr>
-        </p:nvSpPr>
-        <p:spPr/>
-        <p:txBody>
-          <a:bodyPr/>
-          <a:lstStyle/>
-          <a:p>
-            <a:r>
-              <a:t>구조 개선</a:t>
-            </a:r>
-          </a:p>
-        </p:txBody>
-      </p:sp>
-      <p:sp>
-        <p:nvSpPr>
-          <p:cNvPr id="3" name="Content Placeholder 2"/>
-          <p:cNvSpPr>
-            <a:spLocks noGrp="1"/>
-          </p:cNvSpPr>
-          <p:nvPr>
-            <p:ph idx="1"/>
-          </p:nvPr>
-        </p:nvSpPr>
-        <p:spPr/>
-        <p:txBody>
-          <a:bodyPr/>
-          <a:lstStyle/>
-          <a:p>
-            <a:r>
-              <a:t>2026-05-22</a:t>
-            </a:r>
-          </a:p>
-          <a:p>
-            <a:r>
-              <a:t>원종우</a:t>
-            </a:r>
-          </a:p>
-          <a:p>
-            <a:r>
-              <a:t>WebSocket 메시지 발신 표준화(WsEnvelope) 및 DTO 최적화</a:t>
-            </a:r>
-          </a:p>
-          <a:p/>
-          <a:p>
-            <a:r>
-              <a:t>- 프론트엔드 통신 표준화를 위한 공통 이벤트 래퍼 `WsEnvelope` 도입 (event, data, occurredAt, version)</a:t>
-            </a:r>
-          </a:p>
-          <a:p>
-            <a:r>
-              <a:t>- `DailyStandupService`, `MeetingRoomService`, `NotificationService`, `StatusService`, `WorkLogService`의 메시지 전송부를 `WsEnvelope` 규격으로 전면 교체 및 이벤트 명 상수화</a:t>
-            </a:r>
-          </a:p>
-          <a:p>
-            <a:r>
-              <a:t>- 브로드캐스트 전용 DTO를 `WsEnvelope.data` 구조에 맞게 경량화 (`TeamStatusBroadcast` -&gt; `TeamStatusPayload`)</a:t>
-            </a:r>
-          </a:p>
-          <a:p>
-            <a:r>
-              <a:t>- 각 도메인 서비스 내 Member 검증 중복 코드를 `getManagedMember` 등 헬퍼 메서드로 추출 및 알림 페이로드(roomPayload 등) 규격화</a:t>
-            </a:r>
-          </a:p>
-        </p:txBody>
-      </p:sp>
-    </p:spTree>
-  </p:cSld>
-  <p:clrMapOvr>
-    <a:masterClrMapping/>
-  </p:clrMapOvr>
-</p:sld>
-</file>
-
-<file path=ppt/slides/slide11.xml><?xml version="1.0" encoding="utf-8"?>
-<p:sld xmlns:a="http://schemas.openxmlformats.org/drawingml/2006/main" xmlns:p="http://schemas.openxmlformats.org/presentationml/2006/main" xmlns:r="http://schemas.openxmlformats.org/officeDocument/2006/relationships">
-  <p:cSld>
-    <p:spTree>
-      <p:nvGrpSpPr>
-        <p:cNvPr id="1" name=""/>
-        <p:cNvGrpSpPr/>
-        <p:nvPr/>
-      </p:nvGrpSpPr>
-      <p:grpSpPr/>
-      <p:sp>
-        <p:nvSpPr>
-          <p:cNvPr id="2" name="Title 1"/>
-          <p:cNvSpPr>
-            <a:spLocks noGrp="1"/>
-          </p:cNvSpPr>
-          <p:nvPr>
-            <p:ph type="title"/>
-          </p:nvPr>
-        </p:nvSpPr>
-        <p:spPr/>
-        <p:txBody>
-          <a:bodyPr/>
-          <a:lstStyle/>
-          <a:p>
-            <a:r>
-              <a:t>기능 개발</a:t>
-            </a:r>
-          </a:p>
-        </p:txBody>
-      </p:sp>
-      <p:sp>
-        <p:nvSpPr>
-          <p:cNvPr id="3" name="Content Placeholder 2"/>
-          <p:cNvSpPr>
-            <a:spLocks noGrp="1"/>
-          </p:cNvSpPr>
-          <p:nvPr>
-            <p:ph idx="1"/>
-          </p:nvPr>
-        </p:nvSpPr>
-        <p:spPr/>
-        <p:txBody>
-          <a:bodyPr/>
-          <a:lstStyle/>
-          <a:p>
-            <a:r>
-              <a:t>2026-05-22</a:t>
-            </a:r>
-          </a:p>
-          <a:p>
-            <a:r>
-              <a:t>원종우</a:t>
-            </a:r>
-          </a:p>
-          <a:p>
-            <a:r>
-              <a:t>팀 초대 코드 DB 영속화 적용 및 관리 로직 개선</a:t>
-            </a:r>
-          </a:p>
-          <a:p/>
-          <a:p>
-            <a:r>
-              <a:t>- 인메모리(ConcurrentHashMap) 기반 초대 코드 저장을 DB 엔티티(`InviteCode`)로 마이그레이션하여 서버 재시작 시 데이터 유지</a:t>
-            </a:r>
-          </a:p>
-          <a:p>
-            <a:r>
-              <a:t>- 초대 코드 1회성 사용을 위한 `markAsUsed()` 비즈니스 로직 및 검증 추가</a:t>
-            </a:r>
-          </a:p>
-          <a:p>
-            <a:r>
-              <a:t>- 초대 코드 만료 시간(expiration-seconds)을 application.yaml에서 주입받도록 환경변수 처리 개선</a:t>
-            </a:r>
-          </a:p>
-        </p:txBody>
-      </p:sp>
-    </p:spTree>
-  </p:cSld>
-  <p:clrMapOvr>
-    <a:masterClrMapping/>
-  </p:clrMapOvr>
-</p:sld>
-</file>
-
-<file path=ppt/slides/slide12.xml><?xml version="1.0" encoding="utf-8"?>
-<p:sld xmlns:a="http://schemas.openxmlformats.org/drawingml/2006/main" xmlns:p="http://schemas.openxmlformats.org/presentationml/2006/main" xmlns:r="http://schemas.openxmlformats.org/officeDocument/2006/relationships">
-  <p:cSld>
-    <p:spTree>
-      <p:nvGrpSpPr>
-        <p:cNvPr id="1" name=""/>
-        <p:cNvGrpSpPr/>
-        <p:nvPr/>
-      </p:nvGrpSpPr>
-      <p:grpSpPr/>
-      <p:sp>
-        <p:nvSpPr>
-          <p:cNvPr id="2" name="Title 1"/>
-          <p:cNvSpPr>
-            <a:spLocks noGrp="1"/>
-          </p:cNvSpPr>
-          <p:nvPr>
-            <p:ph type="title"/>
-          </p:nvPr>
-        </p:nvSpPr>
-        <p:spPr/>
-        <p:txBody>
-          <a:bodyPr/>
-          <a:lstStyle/>
-          <a:p>
-            <a:r>
-              <a:t>구조 개선</a:t>
-            </a:r>
-          </a:p>
-        </p:txBody>
-      </p:sp>
-      <p:sp>
-        <p:nvSpPr>
-          <p:cNvPr id="3" name="Content Placeholder 2"/>
-          <p:cNvSpPr>
-            <a:spLocks noGrp="1"/>
-          </p:cNvSpPr>
-          <p:nvPr>
-            <p:ph idx="1"/>
-          </p:nvPr>
-        </p:nvSpPr>
-        <p:spPr/>
-        <p:txBody>
-          <a:bodyPr/>
-          <a:lstStyle/>
-          <a:p>
-            <a:r>
-              <a:t>2026-05-21</a:t>
-            </a:r>
-          </a:p>
-          <a:p>
-            <a:r>
-              <a:t>dldnwls07</a:t>
-            </a:r>
-          </a:p>
-          <a:p>
-            <a:r>
-              <a:t>simplify joinRoom signature and optimize media stream management in video calls</a:t>
-            </a:r>
-          </a:p>
-        </p:txBody>
-      </p:sp>
-    </p:spTree>
-  </p:cSld>
-  <p:clrMapOvr>
-    <a:masterClrMapping/>
-  </p:clrMapOvr>
-</p:sld>
-</file>
-
-<file path=ppt/slides/slide13.xml><?xml version="1.0" encoding="utf-8"?>
-<p:sld xmlns:a="http://schemas.openxmlformats.org/drawingml/2006/main" xmlns:p="http://schemas.openxmlformats.org/presentationml/2006/main" xmlns:r="http://schemas.openxmlformats.org/officeDocument/2006/relationships">
-  <p:cSld>
-    <p:spTree>
-      <p:nvGrpSpPr>
-        <p:cNvPr id="1" name=""/>
-        <p:cNvGrpSpPr/>
-        <p:nvPr/>
-      </p:nvGrpSpPr>
-      <p:grpSpPr/>
-      <p:sp>
-        <p:nvSpPr>
-          <p:cNvPr id="2" name="Title 1"/>
-          <p:cNvSpPr>
-            <a:spLocks noGrp="1"/>
-          </p:cNvSpPr>
-          <p:nvPr>
-            <p:ph type="title"/>
-          </p:nvPr>
-        </p:nvSpPr>
-        <p:spPr/>
-        <p:txBody>
-          <a:bodyPr/>
-          <a:lstStyle/>
-          <a:p>
-            <a:r>
-              <a:t>구조 개선</a:t>
-            </a:r>
-          </a:p>
-        </p:txBody>
-      </p:sp>
-      <p:sp>
-        <p:nvSpPr>
-          <p:cNvPr id="3" name="Content Placeholder 2"/>
-          <p:cNvSpPr>
-            <a:spLocks noGrp="1"/>
-          </p:cNvSpPr>
-          <p:nvPr>
-            <p:ph idx="1"/>
-          </p:nvPr>
-        </p:nvSpPr>
-        <p:spPr/>
-        <p:txBody>
-          <a:bodyPr/>
-          <a:lstStyle/>
-          <a:p>
-            <a:r>
-              <a:t>2026-05-21</a:t>
-            </a:r>
-          </a:p>
-          <a:p>
-            <a:r>
-              <a:t>dldnwls07</a:t>
-            </a:r>
-          </a:p>
-          <a:p>
-            <a:r>
-              <a:t>centralize status UI settings and update dashboard WebSocket event handling</a:t>
-            </a:r>
-          </a:p>
-        </p:txBody>
-      </p:sp>
-    </p:spTree>
-  </p:cSld>
-  <p:clrMapOvr>
-    <a:masterClrMapping/>
-  </p:clrMapOvr>
-</p:sld>
-</file>
-
 <file path=ppt/slides/slide2.xml><?xml version="1.0" encoding="utf-8"?>
 <p:sld xmlns:a="http://schemas.openxmlformats.org/drawingml/2006/main" xmlns:p="http://schemas.openxmlformats.org/presentationml/2006/main" xmlns:r="http://schemas.openxmlformats.org/officeDocument/2006/relationships">
   <p:cSld>
@@ -3514,17 +3188,7 @@
           <a:lstStyle/>
           <a:p>
             <a:r>
-              <a:t>원종우: 101 commits</a:t>
-            </a:r>
-          </a:p>
-          <a:p>
-            <a:r>
-              <a:t>dldnwls07: 58 commits</a:t>
-            </a:r>
-          </a:p>
-          <a:p>
-            <a:r>
-              <a:t>070128o: 16 commits</a:t>
+              <a:t>원종우: 1 commits</a:t>
             </a:r>
           </a:p>
           <a:p/>
@@ -3590,182 +3254,7 @@
           </a:p>
           <a:p>
             <a:r>
-              <a:t>- Merge pull request #6 from Jongwoo0101/feature/frontend-refactor-and-bugfix</a:t>
-            </a:r>
-          </a:p>
-          <a:p/>
-          <a:p>
-            <a:r>
-              <a:t> resolve frontend spec issues and fix shared state bug</a:t>
-            </a:r>
-          </a:p>
-          <a:p/>
-          <a:p>
-            <a:r>
-              <a:t>2026-05-23</a:t>
-            </a:r>
-          </a:p>
-          <a:p>
-            <a:r>
-              <a:t>- recover commute state drift when backend worklog is reset</a:t>
-            </a:r>
-          </a:p>
-          <a:p/>
-          <a:p>
-            <a:r>
-              <a:t>2026-05-22</a:t>
-            </a:r>
-          </a:p>
-          <a:p>
-            <a:r>
-              <a:t>- resolve frontend spec issues and fix shared state bug</a:t>
-            </a:r>
-          </a:p>
-          <a:p/>
-          <a:p>
-            <a:r>
-              <a:t>- Segregated Zustand commute store context per employee (fixed shared session bug)</a:t>
-            </a:r>
-          </a:p>
-          <a:p>
-            <a:r>
-              <a:t>- Standardized WebSocket message handling with WS envelope parser</a:t>
-            </a:r>
-          </a:p>
-          <a:p>
-            <a:r>
-              <a:t>- Unified time data sorting with epoch milliseconds</a:t>
-            </a:r>
-          </a:p>
-          <a:p>
-            <a:r>
-              <a:t>- Removed 'any' types for stronger type safety</a:t>
-            </a:r>
-          </a:p>
-          <a:p>
-            <a:r>
-              <a:t>- Separated router pages and content view files</a:t>
-            </a:r>
-          </a:p>
-          <a:p/>
-          <a:p>
-            <a:r>
-              <a:t>2026-05-21</a:t>
-            </a:r>
-          </a:p>
-          <a:p>
-            <a:r>
-              <a:t>- simplify joinRoom signature and optimize media stream management in video calls</a:t>
-            </a:r>
-          </a:p>
-          <a:p/>
-          <a:p>
-            <a:r>
-              <a:t>2026-05-20</a:t>
-            </a:r>
-          </a:p>
-          <a:p>
-            <a:r>
-              <a:t>- chore: status-api-test.http 내에 오타 수정</a:t>
-            </a:r>
-          </a:p>
-          <a:p/>
-          <a:p>
-            <a:r>
-              <a:t>2026-05-15</a:t>
-            </a:r>
-          </a:p>
-          <a:p>
-            <a:r>
-              <a:t>- plan.txt 수정</a:t>
-            </a:r>
-          </a:p>
-          <a:p>
-            <a:r>
-              <a:t>기획완료</a:t>
-            </a:r>
-          </a:p>
-          <a:p/>
-          <a:p>
-            <a:r>
-              <a:t>2026-05-14</a:t>
-            </a:r>
-          </a:p>
-          <a:p>
-            <a:r>
-              <a:t>- refactor(MonitoringService): 트랜잭션 안전성 및 null 처리 개선</a:t>
-            </a:r>
-          </a:p>
-          <a:p/>
-          <a:p>
-            <a:r>
-              <a:t>- WebSocket 브로드캐스팅을 afterCommit() 훅으로 이동</a:t>
-            </a:r>
-          </a:p>
-          <a:p>
-            <a:r>
-              <a:t>  DB 롤백 시 유령 알림 발생 방지</a:t>
-            </a:r>
-          </a:p>
-          <a:p/>
-          <a:p>
-            <a:r>
-              <a:t>- confidence null 처리 개선</a:t>
-            </a:r>
-          </a:p>
-          <a:p>
-            <a:r>
-              <a:t>  Integer nullable 반환 제거, 기본값 0 반환으로 NPE 방지</a:t>
-            </a:r>
-          </a:p>
-          <a:p/>
-          <a:p>
-            <a:r>
-              <a:t>- alert 생성 시 confidence 일관성 확보</a:t>
-            </a:r>
-          </a:p>
-          <a:p>
-            <a:r>
-              <a:t>  event.getConfidence() 대신 normalizeConfidence() 재사용</a:t>
-            </a:r>
-          </a:p>
-          <a:p/>
-          <a:p>
-            <a:r>
-              <a:t>2026-05-13</a:t>
-            </a:r>
-          </a:p>
-          <a:p>
-            <a:r>
-              <a:t>- 팀 스토리지 유틸리티 구현, 모니터링 서비스 유닛 테스트 추가, AI 모델 환경 문제 해결</a:t>
-            </a:r>
-          </a:p>
-          <a:p/>
-          <a:p>
-            <a:r>
-              <a:t>2026-05-12</a:t>
-            </a:r>
-          </a:p>
-          <a:p>
-            <a:r>
-              <a:t>- Merge pull request #5 from Jongwoo0101/frontend</a:t>
-            </a:r>
-          </a:p>
-          <a:p/>
-          <a:p>
-            <a:r>
-              <a:t> 백엔드 보안 설정 수정 및 프론트엔드 실시간 DB 연동 고도화</a:t>
-            </a:r>
-          </a:p>
-          <a:p/>
-          <a:p>
-            <a:r>
-              <a:t>2026-05-10</a:t>
-            </a:r>
-          </a:p>
-          <a:p>
-            <a:r>
-              <a:t>- 백엔드 보안 설정 수정 및 프론트엔드 실시간 DB 연동 고도화</a:t>
+              <a:t>- just for commit bot test. ignore this commit</a:t>
             </a:r>
           </a:p>
           <a:p/>
@@ -3806,7 +3295,7 @@
           <a:lstStyle/>
           <a:p>
             <a:r>
-              <a:t>버그 수정</a:t>
+              <a:t>테스트</a:t>
             </a:r>
           </a:p>
         </p:txBody>
@@ -3827,147 +3316,7 @@
           <a:lstStyle/>
           <a:p>
             <a:r>
-              <a:t>2026-05-23</a:t>
-            </a:r>
-          </a:p>
-          <a:p>
-            <a:r>
-              <a:t>dldnwls07</a:t>
-            </a:r>
-          </a:p>
-          <a:p>
-            <a:r>
-              <a:t>recover commute state drift when backend worklog is reset</a:t>
-            </a:r>
-          </a:p>
-        </p:txBody>
-      </p:sp>
-    </p:spTree>
-  </p:cSld>
-  <p:clrMapOvr>
-    <a:masterClrMapping/>
-  </p:clrMapOvr>
-</p:sld>
-</file>
-
-<file path=ppt/slides/slide5.xml><?xml version="1.0" encoding="utf-8"?>
-<p:sld xmlns:a="http://schemas.openxmlformats.org/drawingml/2006/main" xmlns:p="http://schemas.openxmlformats.org/presentationml/2006/main" xmlns:r="http://schemas.openxmlformats.org/officeDocument/2006/relationships">
-  <p:cSld>
-    <p:spTree>
-      <p:nvGrpSpPr>
-        <p:cNvPr id="1" name=""/>
-        <p:cNvGrpSpPr/>
-        <p:nvPr/>
-      </p:nvGrpSpPr>
-      <p:grpSpPr/>
-      <p:sp>
-        <p:nvSpPr>
-          <p:cNvPr id="2" name="Title 1"/>
-          <p:cNvSpPr>
-            <a:spLocks noGrp="1"/>
-          </p:cNvSpPr>
-          <p:nvPr>
-            <p:ph type="title"/>
-          </p:nvPr>
-        </p:nvSpPr>
-        <p:spPr/>
-        <p:txBody>
-          <a:bodyPr/>
-          <a:lstStyle/>
-          <a:p>
-            <a:r>
-              <a:t>기능 개발</a:t>
-            </a:r>
-          </a:p>
-        </p:txBody>
-      </p:sp>
-      <p:sp>
-        <p:nvSpPr>
-          <p:cNvPr id="3" name="Content Placeholder 2"/>
-          <p:cNvSpPr>
-            <a:spLocks noGrp="1"/>
-          </p:cNvSpPr>
-          <p:nvPr>
-            <p:ph idx="1"/>
-          </p:nvPr>
-        </p:nvSpPr>
-        <p:spPr/>
-        <p:txBody>
-          <a:bodyPr/>
-          <a:lstStyle/>
-          <a:p>
-            <a:r>
-              <a:t>2026-05-23</a:t>
-            </a:r>
-          </a:p>
-          <a:p>
-            <a:r>
-              <a:t>dldnwls07</a:t>
-            </a:r>
-          </a:p>
-          <a:p>
-            <a:r>
-              <a:t>include participantId in meeting notifications and refactor team store selectors for improved reactivity</a:t>
-            </a:r>
-          </a:p>
-        </p:txBody>
-      </p:sp>
-    </p:spTree>
-  </p:cSld>
-  <p:clrMapOvr>
-    <a:masterClrMapping/>
-  </p:clrMapOvr>
-</p:sld>
-</file>
-
-<file path=ppt/slides/slide6.xml><?xml version="1.0" encoding="utf-8"?>
-<p:sld xmlns:a="http://schemas.openxmlformats.org/drawingml/2006/main" xmlns:p="http://schemas.openxmlformats.org/presentationml/2006/main" xmlns:r="http://schemas.openxmlformats.org/officeDocument/2006/relationships">
-  <p:cSld>
-    <p:spTree>
-      <p:nvGrpSpPr>
-        <p:cNvPr id="1" name=""/>
-        <p:cNvGrpSpPr/>
-        <p:nvPr/>
-      </p:nvGrpSpPr>
-      <p:grpSpPr/>
-      <p:sp>
-        <p:nvSpPr>
-          <p:cNvPr id="2" name="Title 1"/>
-          <p:cNvSpPr>
-            <a:spLocks noGrp="1"/>
-          </p:cNvSpPr>
-          <p:nvPr>
-            <p:ph type="title"/>
-          </p:nvPr>
-        </p:nvSpPr>
-        <p:spPr/>
-        <p:txBody>
-          <a:bodyPr/>
-          <a:lstStyle/>
-          <a:p>
-            <a:r>
-              <a:t>버그 수정</a:t>
-            </a:r>
-          </a:p>
-        </p:txBody>
-      </p:sp>
-      <p:sp>
-        <p:nvSpPr>
-          <p:cNvPr id="3" name="Content Placeholder 2"/>
-          <p:cNvSpPr>
-            <a:spLocks noGrp="1"/>
-          </p:cNvSpPr>
-          <p:nvPr>
-            <p:ph idx="1"/>
-          </p:nvPr>
-        </p:nvSpPr>
-        <p:spPr/>
-        <p:txBody>
-          <a:bodyPr/>
-          <a:lstStyle/>
-          <a:p>
-            <a:r>
-              <a:t>2026-05-23</a:t>
+              <a:t>2026-05-24</a:t>
             </a:r>
           </a:p>
           <a:p>
@@ -3977,274 +3326,7 @@
           </a:p>
           <a:p>
             <a:r>
-              <a:t>화상회의 방 재입장 시 호스트/참가자 상태 동기화 및 모달 미표시 버그 수정</a:t>
-            </a:r>
-          </a:p>
-        </p:txBody>
-      </p:sp>
-    </p:spTree>
-  </p:cSld>
-  <p:clrMapOvr>
-    <a:masterClrMapping/>
-  </p:clrMapOvr>
-</p:sld>
-</file>
-
-<file path=ppt/slides/slide7.xml><?xml version="1.0" encoding="utf-8"?>
-<p:sld xmlns:a="http://schemas.openxmlformats.org/drawingml/2006/main" xmlns:p="http://schemas.openxmlformats.org/presentationml/2006/main" xmlns:r="http://schemas.openxmlformats.org/officeDocument/2006/relationships">
-  <p:cSld>
-    <p:spTree>
-      <p:nvGrpSpPr>
-        <p:cNvPr id="1" name=""/>
-        <p:cNvGrpSpPr/>
-        <p:nvPr/>
-      </p:nvGrpSpPr>
-      <p:grpSpPr/>
-      <p:sp>
-        <p:nvSpPr>
-          <p:cNvPr id="2" name="Title 1"/>
-          <p:cNvSpPr>
-            <a:spLocks noGrp="1"/>
-          </p:cNvSpPr>
-          <p:nvPr>
-            <p:ph type="title"/>
-          </p:nvPr>
-        </p:nvSpPr>
-        <p:spPr/>
-        <p:txBody>
-          <a:bodyPr/>
-          <a:lstStyle/>
-          <a:p>
-            <a:r>
-              <a:t>버그 수정</a:t>
-            </a:r>
-          </a:p>
-        </p:txBody>
-      </p:sp>
-      <p:sp>
-        <p:nvSpPr>
-          <p:cNvPr id="3" name="Content Placeholder 2"/>
-          <p:cNvSpPr>
-            <a:spLocks noGrp="1"/>
-          </p:cNvSpPr>
-          <p:nvPr>
-            <p:ph idx="1"/>
-          </p:nvPr>
-        </p:nvSpPr>
-        <p:spPr/>
-        <p:txBody>
-          <a:bodyPr/>
-          <a:lstStyle/>
-          <a:p>
-            <a:r>
-              <a:t>2026-05-23</a:t>
-            </a:r>
-          </a:p>
-          <a:p>
-            <a:r>
-              <a:t>원종우</a:t>
-            </a:r>
-          </a:p>
-          <a:p>
-            <a:r>
-              <a:t>SecurityConfig.java @Value 제거</a:t>
-            </a:r>
-          </a:p>
-          <a:p>
-            <a:r>
-              <a:t>localhost:5173 하드코딩 유지. 대신 새 API 경로들(/api/meetings/**, /api/notifications/**, /api/standup/**) 추가된 것만 반영</a:t>
-            </a:r>
-          </a:p>
-        </p:txBody>
-      </p:sp>
-    </p:spTree>
-  </p:cSld>
-  <p:clrMapOvr>
-    <a:masterClrMapping/>
-  </p:clrMapOvr>
-</p:sld>
-</file>
-
-<file path=ppt/slides/slide8.xml><?xml version="1.0" encoding="utf-8"?>
-<p:sld xmlns:a="http://schemas.openxmlformats.org/drawingml/2006/main" xmlns:p="http://schemas.openxmlformats.org/presentationml/2006/main" xmlns:r="http://schemas.openxmlformats.org/officeDocument/2006/relationships">
-  <p:cSld>
-    <p:spTree>
-      <p:nvGrpSpPr>
-        <p:cNvPr id="1" name=""/>
-        <p:cNvGrpSpPr/>
-        <p:nvPr/>
-      </p:nvGrpSpPr>
-      <p:grpSpPr/>
-      <p:sp>
-        <p:nvSpPr>
-          <p:cNvPr id="2" name="Title 1"/>
-          <p:cNvSpPr>
-            <a:spLocks noGrp="1"/>
-          </p:cNvSpPr>
-          <p:nvPr>
-            <p:ph type="title"/>
-          </p:nvPr>
-        </p:nvSpPr>
-        <p:spPr/>
-        <p:txBody>
-          <a:bodyPr/>
-          <a:lstStyle/>
-          <a:p>
-            <a:r>
-              <a:t>구조 개선</a:t>
-            </a:r>
-          </a:p>
-        </p:txBody>
-      </p:sp>
-      <p:sp>
-        <p:nvSpPr>
-          <p:cNvPr id="3" name="Content Placeholder 2"/>
-          <p:cNvSpPr>
-            <a:spLocks noGrp="1"/>
-          </p:cNvSpPr>
-          <p:nvPr>
-            <p:ph idx="1"/>
-          </p:nvPr>
-        </p:nvSpPr>
-        <p:spPr/>
-        <p:txBody>
-          <a:bodyPr/>
-          <a:lstStyle/>
-          <a:p>
-            <a:r>
-              <a:t>2026-05-22</a:t>
-            </a:r>
-          </a:p>
-          <a:p>
-            <a:r>
-              <a:t>dldnwls07</a:t>
-            </a:r>
-          </a:p>
-          <a:p>
-            <a:r>
-              <a:t>resolve frontend spec issues and fix shared state bug</a:t>
-            </a:r>
-          </a:p>
-          <a:p/>
-          <a:p>
-            <a:r>
-              <a:t>- Segregated Zustand commute store context per employee (fixed shared session bug)</a:t>
-            </a:r>
-          </a:p>
-          <a:p>
-            <a:r>
-              <a:t>- Standardized WebSocket message handling with WS envelope parser</a:t>
-            </a:r>
-          </a:p>
-          <a:p>
-            <a:r>
-              <a:t>- Unified time data sorting with epoch milliseconds</a:t>
-            </a:r>
-          </a:p>
-          <a:p>
-            <a:r>
-              <a:t>- Removed 'any' types for stronger type safety</a:t>
-            </a:r>
-          </a:p>
-          <a:p>
-            <a:r>
-              <a:t>- Separated router pages and content view files</a:t>
-            </a:r>
-          </a:p>
-        </p:txBody>
-      </p:sp>
-    </p:spTree>
-  </p:cSld>
-  <p:clrMapOvr>
-    <a:masterClrMapping/>
-  </p:clrMapOvr>
-</p:sld>
-</file>
-
-<file path=ppt/slides/slide9.xml><?xml version="1.0" encoding="utf-8"?>
-<p:sld xmlns:a="http://schemas.openxmlformats.org/drawingml/2006/main" xmlns:p="http://schemas.openxmlformats.org/presentationml/2006/main" xmlns:r="http://schemas.openxmlformats.org/officeDocument/2006/relationships">
-  <p:cSld>
-    <p:spTree>
-      <p:nvGrpSpPr>
-        <p:cNvPr id="1" name=""/>
-        <p:cNvGrpSpPr/>
-        <p:nvPr/>
-      </p:nvGrpSpPr>
-      <p:grpSpPr/>
-      <p:sp>
-        <p:nvSpPr>
-          <p:cNvPr id="2" name="Title 1"/>
-          <p:cNvSpPr>
-            <a:spLocks noGrp="1"/>
-          </p:cNvSpPr>
-          <p:nvPr>
-            <p:ph type="title"/>
-          </p:nvPr>
-        </p:nvSpPr>
-        <p:spPr/>
-        <p:txBody>
-          <a:bodyPr/>
-          <a:lstStyle/>
-          <a:p>
-            <a:r>
-              <a:t>기능 개발</a:t>
-            </a:r>
-          </a:p>
-        </p:txBody>
-      </p:sp>
-      <p:sp>
-        <p:nvSpPr>
-          <p:cNvPr id="3" name="Content Placeholder 2"/>
-          <p:cNvSpPr>
-            <a:spLocks noGrp="1"/>
-          </p:cNvSpPr>
-          <p:nvPr>
-            <p:ph idx="1"/>
-          </p:nvPr>
-        </p:nvSpPr>
-        <p:spPr/>
-        <p:txBody>
-          <a:bodyPr/>
-          <a:lstStyle/>
-          <a:p>
-            <a:r>
-              <a:t>2026-05-22</a:t>
-            </a:r>
-          </a:p>
-          <a:p>
-            <a:r>
-              <a:t>원종우</a:t>
-            </a:r>
-          </a:p>
-          <a:p>
-            <a:r>
-              <a:t>팀 초대 코드 다회성 사용을 위한 1회성 제한 로직 제거</a:t>
-            </a:r>
-          </a:p>
-          <a:p/>
-          <a:p>
-            <a:r>
-              <a:t>[주요 변경 사항]</a:t>
-            </a:r>
-          </a:p>
-          <a:p>
-            <a:r>
-              <a:t>- 기존 1회성 사용 제한으로 인해 다른 팀원이 동일한 코드로 연이어 참가하지 못하던 문제 해결</a:t>
-            </a:r>
-          </a:p>
-          <a:p>
-            <a:r>
-              <a:t>- `InviteCode` 엔티티에서 불필요해진 `used` 필드 및 `markAsUsed()` 상태 변경 메서드 삭제</a:t>
-            </a:r>
-          </a:p>
-          <a:p>
-            <a:r>
-              <a:t>- `InviteCodeRepository`의 쿼리 메서드를 `findByCodeAndUsedFalse`에서 `findByCode`로 단순화</a:t>
-            </a:r>
-          </a:p>
-          <a:p>
-            <a:r>
-              <a:t>- `MemberService.joinTeam()` 내 1회성 처리 로직을 제거하여, 지정된 만료 시간(기본 5분) 내에는 여러 팀원이 무제한으로 코드를 사용할 수 있도록 비즈니스 로직 개선</a:t>
+              <a:t>just for commit bot test. ignore this commit</a:t>
             </a:r>
           </a:p>
         </p:txBody>

</xml_diff>